<commit_message>
refactor(presentation): 본문을 PowerPoint 기본 불릿으로 (직접 편집 가능)
- 수동 마커 -> ppt 기본 bullet + indentLevel (Tab 들여쓰기·자동 불릿 동작)
- 강조는 항목 단위 (pptxgenjs는 부분강조+불릿 동시 불가)

Co-Authored-By: Claude Opus 4.8 <noreply@anthropic.com>
</commit_message>
<xml_diff>
--- a/term-project-lstm-vs-transformer-agnews/deliverables/5_presentation_v2.pptx
+++ b/term-project-lstm-vs-transformer-agnews/deliverables/5_presentation_v2.pptx
@@ -2407,63 +2407,33 @@
             <a:endParaRPr lang="en-US" sz="1650" dirty="0"/>
           </a:p>
           <a:p>
-            <a:pPr lvl="1" indent="0" marL="0">
-              <a:buNone/>
-            </a:pPr>
-            <a:r>
-              <a:rPr lang="en-US" sz="1250" dirty="0">
-                <a:solidFill>
-                  <a:srgbClr val="1D4ED8"/>
-                </a:solidFill>
-                <a:latin typeface="Pretendard" pitchFamily="34" charset="0"/>
-                <a:ea typeface="Pretendard" pitchFamily="34" charset="-122"/>
-                <a:cs typeface="Pretendard" pitchFamily="34" charset="-120"/>
-              </a:rPr>
-              <a:t>●   </a:t>
-            </a:r>
-            <a:pPr lvl="1" indent="0" marL="0">
-              <a:lnSpc>
-                <a:spcPct val="120000"/>
-              </a:lnSpc>
-              <a:buNone/>
-            </a:pPr>
-            <a:r>
-              <a:rPr lang="en-US" sz="1500" b="1" dirty="0">
-                <a:solidFill>
-                  <a:srgbClr val="111827"/>
-                </a:solidFill>
-                <a:latin typeface="Pretendard" pitchFamily="34" charset="0"/>
-                <a:ea typeface="Pretendard" pitchFamily="34" charset="-122"/>
-                <a:cs typeface="Pretendard" pitchFamily="34" charset="-120"/>
-              </a:rPr>
-              <a:t>동일 조건에서 test accuracy 0.910 vs 0.833</a:t>
-            </a:r>
-            <a:pPr lvl="1" indent="0" marL="0">
-              <a:lnSpc>
-                <a:spcPct val="120000"/>
+            <a:pPr lvl="1" marL="457200" indent="-228600">
+              <a:lnSpc>
+                <a:spcPct val="125000"/>
               </a:lnSpc>
               <a:spcAft>
                 <a:spcPts val="500"/>
               </a:spcAft>
-              <a:buNone/>
-            </a:pPr>
-            <a:r>
-              <a:rPr lang="en-US" sz="1500" dirty="0">
-                <a:solidFill>
-                  <a:srgbClr val="374151"/>
-                </a:solidFill>
-                <a:latin typeface="Pretendard" pitchFamily="34" charset="0"/>
-                <a:ea typeface="Pretendard" pitchFamily="34" charset="-122"/>
-                <a:cs typeface="Pretendard" pitchFamily="34" charset="-120"/>
-              </a:rPr>
-              <a:t> (encoder 구조만 바꾼 통제된 비교)</a:t>
+              <a:buSzPct val="100000"/>
+              <a:buChar char="●"/>
+            </a:pPr>
+            <a:r>
+              <a:rPr lang="en-US" sz="1500" b="1" dirty="0">
+                <a:solidFill>
+                  <a:srgbClr val="111827"/>
+                </a:solidFill>
+                <a:latin typeface="Pretendard" pitchFamily="34" charset="0"/>
+                <a:ea typeface="Pretendard" pitchFamily="34" charset="-122"/>
+                <a:cs typeface="Pretendard" pitchFamily="34" charset="-120"/>
+              </a:rPr>
+              <a:t>동일 조건에서 test accuracy 0.910 vs 0.833 (encoder 구조만 바꾼 통제된 비교)</a:t>
             </a:r>
             <a:endParaRPr lang="en-US" sz="1650" dirty="0"/>
           </a:p>
           <a:p>
             <a:pPr indent="0" marL="0">
               <a:spcBef>
-                <a:spcPts val="1500"/>
+                <a:spcPts val="1400"/>
               </a:spcBef>
               <a:spcAft>
                 <a:spcPts val="700"/>
@@ -2484,63 +2454,33 @@
             <a:endParaRPr lang="en-US" sz="1650" dirty="0"/>
           </a:p>
           <a:p>
-            <a:pPr lvl="1" indent="0" marL="0">
-              <a:buNone/>
-            </a:pPr>
-            <a:r>
-              <a:rPr lang="en-US" sz="1250" dirty="0">
-                <a:solidFill>
-                  <a:srgbClr val="1D4ED8"/>
-                </a:solidFill>
-                <a:latin typeface="Pretendard" pitchFamily="34" charset="0"/>
-                <a:ea typeface="Pretendard" pitchFamily="34" charset="-122"/>
-                <a:cs typeface="Pretendard" pitchFamily="34" charset="-120"/>
-              </a:rPr>
-              <a:t>●   </a:t>
-            </a:r>
-            <a:pPr lvl="1" indent="0" marL="0">
-              <a:lnSpc>
-                <a:spcPct val="120000"/>
-              </a:lnSpc>
-              <a:buNone/>
-            </a:pPr>
-            <a:r>
-              <a:rPr lang="en-US" sz="1500" b="1" dirty="0">
-                <a:solidFill>
-                  <a:srgbClr val="111827"/>
-                </a:solidFill>
-                <a:latin typeface="Pretendard" pitchFamily="34" charset="0"/>
-                <a:ea typeface="Pretendard" pitchFamily="34" charset="-122"/>
-                <a:cs typeface="Pretendard" pitchFamily="34" charset="-120"/>
-              </a:rPr>
-              <a:t>generalization 차이</a:t>
-            </a:r>
-            <a:pPr lvl="1" indent="0" marL="0">
-              <a:lnSpc>
-                <a:spcPct val="120000"/>
+            <a:pPr lvl="1" marL="457200" indent="-228600">
+              <a:lnSpc>
+                <a:spcPct val="125000"/>
               </a:lnSpc>
               <a:spcAft>
                 <a:spcPts val="500"/>
               </a:spcAft>
-              <a:buNone/>
-            </a:pPr>
-            <a:r>
-              <a:rPr lang="en-US" sz="1500" dirty="0">
-                <a:solidFill>
-                  <a:srgbClr val="374151"/>
-                </a:solidFill>
-                <a:latin typeface="Pretendard" pitchFamily="34" charset="0"/>
-                <a:ea typeface="Pretendard" pitchFamily="34" charset="-122"/>
-                <a:cs typeface="Pretendard" pitchFamily="34" charset="-120"/>
-              </a:rPr>
-              <a:t>: LSTM은 overfitting하여 25%에서 포화, Transformer는 안정적으로 확장</a:t>
+              <a:buSzPct val="100000"/>
+              <a:buChar char="●"/>
+            </a:pPr>
+            <a:r>
+              <a:rPr lang="en-US" sz="1500" b="1" dirty="0">
+                <a:solidFill>
+                  <a:srgbClr val="111827"/>
+                </a:solidFill>
+                <a:latin typeface="Pretendard" pitchFamily="34" charset="0"/>
+                <a:ea typeface="Pretendard" pitchFamily="34" charset="-122"/>
+                <a:cs typeface="Pretendard" pitchFamily="34" charset="-120"/>
+              </a:rPr>
+              <a:t>generalization 차이 : LSTM은 overfitting하여 25%에서 포화, Transformer는 안정적으로 확장</a:t>
             </a:r>
             <a:endParaRPr lang="en-US" sz="1650" dirty="0"/>
           </a:p>
           <a:p>
             <a:pPr indent="0" marL="0">
               <a:spcBef>
-                <a:spcPts val="1500"/>
+                <a:spcPts val="1400"/>
               </a:spcBef>
               <a:spcAft>
                 <a:spcPts val="700"/>
@@ -2561,63 +2501,33 @@
             <a:endParaRPr lang="en-US" sz="1650" dirty="0"/>
           </a:p>
           <a:p>
-            <a:pPr lvl="1" indent="0" marL="0">
-              <a:buNone/>
-            </a:pPr>
-            <a:r>
-              <a:rPr lang="en-US" sz="1250" dirty="0">
-                <a:solidFill>
-                  <a:srgbClr val="1D4ED8"/>
-                </a:solidFill>
-                <a:latin typeface="Pretendard" pitchFamily="34" charset="0"/>
-                <a:ea typeface="Pretendard" pitchFamily="34" charset="-122"/>
-                <a:cs typeface="Pretendard" pitchFamily="34" charset="-120"/>
-              </a:rPr>
-              <a:t>●   </a:t>
-            </a:r>
-            <a:pPr lvl="1" indent="0" marL="0">
-              <a:lnSpc>
-                <a:spcPct val="120000"/>
-              </a:lnSpc>
-              <a:buNone/>
-            </a:pPr>
-            <a:r>
-              <a:rPr lang="en-US" sz="1500" b="1" dirty="0">
-                <a:solidFill>
-                  <a:srgbClr val="111827"/>
-                </a:solidFill>
-                <a:latin typeface="Pretendard" pitchFamily="34" charset="0"/>
-                <a:ea typeface="Pretendard" pitchFamily="34" charset="-122"/>
-                <a:cs typeface="Pretendard" pitchFamily="34" charset="-120"/>
-              </a:rPr>
-              <a:t>bag-of-words</a:t>
-            </a:r>
-            <a:pPr lvl="1" indent="0" marL="0">
-              <a:lnSpc>
-                <a:spcPct val="120000"/>
+            <a:pPr lvl="1" marL="457200" indent="-228600">
+              <a:lnSpc>
+                <a:spcPct val="125000"/>
               </a:lnSpc>
               <a:spcAft>
                 <a:spcPts val="500"/>
               </a:spcAft>
-              <a:buNone/>
-            </a:pPr>
-            <a:r>
-              <a:rPr lang="en-US" sz="1500" dirty="0">
-                <a:solidFill>
-                  <a:srgbClr val="374151"/>
-                </a:solidFill>
-                <a:latin typeface="Pretendard" pitchFamily="34" charset="0"/>
-                <a:ea typeface="Pretendard" pitchFamily="34" charset="-122"/>
-                <a:cs typeface="Pretendard" pitchFamily="34" charset="-120"/>
-              </a:rPr>
-              <a:t>: positional encoding 제거해도 정확도 동일 → 격차는 순서가 아닌 robustness</a:t>
+              <a:buSzPct val="100000"/>
+              <a:buChar char="●"/>
+            </a:pPr>
+            <a:r>
+              <a:rPr lang="en-US" sz="1500" b="1" dirty="0">
+                <a:solidFill>
+                  <a:srgbClr val="111827"/>
+                </a:solidFill>
+                <a:latin typeface="Pretendard" pitchFamily="34" charset="0"/>
+                <a:ea typeface="Pretendard" pitchFamily="34" charset="-122"/>
+                <a:cs typeface="Pretendard" pitchFamily="34" charset="-120"/>
+              </a:rPr>
+              <a:t>bag-of-words : positional encoding 제거해도 정확도 동일 → 격차는 순서가 아닌 robustness</a:t>
             </a:r>
             <a:endParaRPr lang="en-US" sz="1650" dirty="0"/>
           </a:p>
           <a:p>
             <a:pPr indent="0" marL="0">
               <a:spcBef>
-                <a:spcPts val="1500"/>
+                <a:spcPts val="1400"/>
               </a:spcBef>
               <a:spcAft>
                 <a:spcPts val="700"/>
@@ -2638,28 +2548,15 @@
             <a:endParaRPr lang="en-US" sz="1650" dirty="0"/>
           </a:p>
           <a:p>
-            <a:pPr lvl="1" indent="0" marL="0">
-              <a:buNone/>
-            </a:pPr>
-            <a:r>
-              <a:rPr lang="en-US" sz="1250" dirty="0">
-                <a:solidFill>
-                  <a:srgbClr val="1D4ED8"/>
-                </a:solidFill>
-                <a:latin typeface="Pretendard" pitchFamily="34" charset="0"/>
-                <a:ea typeface="Pretendard" pitchFamily="34" charset="-122"/>
-                <a:cs typeface="Pretendard" pitchFamily="34" charset="-120"/>
-              </a:rPr>
-              <a:t>●   </a:t>
-            </a:r>
-            <a:pPr lvl="1" indent="0" marL="0">
-              <a:lnSpc>
-                <a:spcPct val="120000"/>
+            <a:pPr lvl="1" marL="457200" indent="-228600">
+              <a:lnSpc>
+                <a:spcPct val="125000"/>
               </a:lnSpc>
               <a:spcAft>
                 <a:spcPts val="500"/>
               </a:spcAft>
-              <a:buNone/>
+              <a:buSzPct val="100000"/>
+              <a:buChar char="●"/>
             </a:pPr>
             <a:r>
               <a:rPr lang="en-US" sz="1500" dirty="0">
@@ -2675,28 +2572,15 @@
             <a:endParaRPr lang="en-US" sz="1650" dirty="0"/>
           </a:p>
           <a:p>
-            <a:pPr lvl="1" indent="0" marL="0">
-              <a:buNone/>
-            </a:pPr>
-            <a:r>
-              <a:rPr lang="en-US" sz="1250" dirty="0">
-                <a:solidFill>
-                  <a:srgbClr val="1D4ED8"/>
-                </a:solidFill>
-                <a:latin typeface="Pretendard" pitchFamily="34" charset="0"/>
-                <a:ea typeface="Pretendard" pitchFamily="34" charset="-122"/>
-                <a:cs typeface="Pretendard" pitchFamily="34" charset="-120"/>
-              </a:rPr>
-              <a:t>●   </a:t>
-            </a:r>
-            <a:pPr lvl="1" indent="0" marL="0">
-              <a:lnSpc>
-                <a:spcPct val="120000"/>
+            <a:pPr lvl="1" marL="457200" indent="-228600">
+              <a:lnSpc>
+                <a:spcPct val="125000"/>
               </a:lnSpc>
               <a:spcAft>
                 <a:spcPts val="500"/>
               </a:spcAft>
-              <a:buNone/>
+              <a:buSzPct val="100000"/>
+              <a:buChar char="●"/>
             </a:pPr>
             <a:r>
               <a:rPr lang="en-US" sz="1500" dirty="0">
@@ -3024,82 +2908,39 @@
             <a:endParaRPr lang="en-US" sz="1650" dirty="0"/>
           </a:p>
           <a:p>
-            <a:pPr lvl="1" indent="0" marL="0">
-              <a:buNone/>
-            </a:pPr>
-            <a:r>
-              <a:rPr lang="en-US" sz="1250" dirty="0">
-                <a:solidFill>
-                  <a:srgbClr val="1D4ED8"/>
-                </a:solidFill>
-                <a:latin typeface="Pretendard" pitchFamily="34" charset="0"/>
-                <a:ea typeface="Pretendard" pitchFamily="34" charset="-122"/>
-                <a:cs typeface="Pretendard" pitchFamily="34" charset="-120"/>
-              </a:rPr>
-              <a:t>●   </a:t>
-            </a:r>
-            <a:pPr lvl="1" indent="0" marL="0">
-              <a:lnSpc>
-                <a:spcPct val="120000"/>
-              </a:lnSpc>
-              <a:buNone/>
-            </a:pPr>
-            <a:r>
-              <a:rPr lang="en-US" sz="1500" b="1" dirty="0">
-                <a:solidFill>
-                  <a:srgbClr val="111827"/>
-                </a:solidFill>
-                <a:latin typeface="Pretendard" pitchFamily="34" charset="0"/>
-                <a:ea typeface="Pretendard" pitchFamily="34" charset="-122"/>
-                <a:cs typeface="Pretendard" pitchFamily="34" charset="-120"/>
-              </a:rPr>
-              <a:t>AG News 4-class 뉴스 주제 분류</a:t>
-            </a:r>
-            <a:pPr lvl="1" indent="0" marL="0">
-              <a:lnSpc>
-                <a:spcPct val="120000"/>
+            <a:pPr lvl="1" marL="457200" indent="-228600">
+              <a:lnSpc>
+                <a:spcPct val="125000"/>
               </a:lnSpc>
               <a:spcAft>
                 <a:spcPts val="500"/>
               </a:spcAft>
-              <a:buNone/>
-            </a:pPr>
-            <a:r>
-              <a:rPr lang="en-US" sz="1500" dirty="0">
-                <a:solidFill>
-                  <a:srgbClr val="374151"/>
-                </a:solidFill>
-                <a:latin typeface="Pretendard" pitchFamily="34" charset="0"/>
-                <a:ea typeface="Pretendard" pitchFamily="34" charset="-122"/>
-                <a:cs typeface="Pretendard" pitchFamily="34" charset="-120"/>
-              </a:rPr>
-              <a:t> (World·Sports·Business·Sci-Tech)</a:t>
+              <a:buSzPct val="100000"/>
+              <a:buChar char="●"/>
+            </a:pPr>
+            <a:r>
+              <a:rPr lang="en-US" sz="1500" b="1" dirty="0">
+                <a:solidFill>
+                  <a:srgbClr val="111827"/>
+                </a:solidFill>
+                <a:latin typeface="Pretendard" pitchFamily="34" charset="0"/>
+                <a:ea typeface="Pretendard" pitchFamily="34" charset="-122"/>
+                <a:cs typeface="Pretendard" pitchFamily="34" charset="-120"/>
+              </a:rPr>
+              <a:t>AG News 4-class 뉴스 주제 분류 (World·Sports·Business·Sci-Tech)</a:t>
             </a:r>
             <a:endParaRPr lang="en-US" sz="1650" dirty="0"/>
           </a:p>
           <a:p>
-            <a:pPr lvl="1" indent="0" marL="0">
-              <a:buNone/>
-            </a:pPr>
-            <a:r>
-              <a:rPr lang="en-US" sz="1250" dirty="0">
-                <a:solidFill>
-                  <a:srgbClr val="1D4ED8"/>
-                </a:solidFill>
-                <a:latin typeface="Pretendard" pitchFamily="34" charset="0"/>
-                <a:ea typeface="Pretendard" pitchFamily="34" charset="-122"/>
-                <a:cs typeface="Pretendard" pitchFamily="34" charset="-120"/>
-              </a:rPr>
-              <a:t>●   </a:t>
-            </a:r>
-            <a:pPr lvl="1" indent="0" marL="0">
-              <a:lnSpc>
-                <a:spcPct val="120000"/>
+            <a:pPr lvl="1" marL="457200" indent="-228600">
+              <a:lnSpc>
+                <a:spcPct val="125000"/>
               </a:lnSpc>
               <a:spcAft>
                 <a:spcPts val="500"/>
               </a:spcAft>
-              <a:buNone/>
+              <a:buSzPct val="100000"/>
+              <a:buChar char="●"/>
             </a:pPr>
             <a:r>
               <a:rPr lang="en-US" sz="1500" dirty="0">
@@ -3117,7 +2958,7 @@
           <a:p>
             <a:pPr indent="0" marL="0">
               <a:spcBef>
-                <a:spcPts val="1800"/>
+                <a:spcPts val="1500"/>
               </a:spcBef>
               <a:spcAft>
                 <a:spcPts val="700"/>
@@ -3138,82 +2979,39 @@
             <a:endParaRPr lang="en-US" sz="1650" dirty="0"/>
           </a:p>
           <a:p>
-            <a:pPr lvl="1" indent="0" marL="0">
-              <a:buNone/>
-            </a:pPr>
-            <a:r>
-              <a:rPr lang="en-US" sz="1250" dirty="0">
-                <a:solidFill>
-                  <a:srgbClr val="1D4ED8"/>
-                </a:solidFill>
-                <a:latin typeface="Pretendard" pitchFamily="34" charset="0"/>
-                <a:ea typeface="Pretendard" pitchFamily="34" charset="-122"/>
-                <a:cs typeface="Pretendard" pitchFamily="34" charset="-120"/>
-              </a:rPr>
-              <a:t>●   </a:t>
-            </a:r>
-            <a:pPr lvl="1" indent="0" marL="0">
-              <a:lnSpc>
-                <a:spcPct val="120000"/>
-              </a:lnSpc>
-              <a:buNone/>
-            </a:pPr>
-            <a:r>
-              <a:rPr lang="en-US" sz="1500" b="1" dirty="0">
-                <a:solidFill>
-                  <a:srgbClr val="111827"/>
-                </a:solidFill>
-                <a:latin typeface="Pretendard" pitchFamily="34" charset="0"/>
-                <a:ea typeface="Pretendard" pitchFamily="34" charset="-122"/>
-                <a:cs typeface="Pretendard" pitchFamily="34" charset="-120"/>
-              </a:rPr>
-              <a:t>데이터·전처리·어휘·시퀀스 길이·학습 예산</a:t>
-            </a:r>
-            <a:pPr lvl="1" indent="0" marL="0">
-              <a:lnSpc>
-                <a:spcPct val="120000"/>
+            <a:pPr lvl="1" marL="457200" indent="-228600">
+              <a:lnSpc>
+                <a:spcPct val="125000"/>
               </a:lnSpc>
               <a:spcAft>
                 <a:spcPts val="500"/>
               </a:spcAft>
-              <a:buNone/>
-            </a:pPr>
-            <a:r>
-              <a:rPr lang="en-US" sz="1500" dirty="0">
-                <a:solidFill>
-                  <a:srgbClr val="374151"/>
-                </a:solidFill>
-                <a:latin typeface="Pretendard" pitchFamily="34" charset="0"/>
-                <a:ea typeface="Pretendard" pitchFamily="34" charset="-122"/>
-                <a:cs typeface="Pretendard" pitchFamily="34" charset="-120"/>
-              </a:rPr>
-              <a:t>을 동일하게 고정</a:t>
+              <a:buSzPct val="100000"/>
+              <a:buChar char="●"/>
+            </a:pPr>
+            <a:r>
+              <a:rPr lang="en-US" sz="1500" b="1" dirty="0">
+                <a:solidFill>
+                  <a:srgbClr val="111827"/>
+                </a:solidFill>
+                <a:latin typeface="Pretendard" pitchFamily="34" charset="0"/>
+                <a:ea typeface="Pretendard" pitchFamily="34" charset="-122"/>
+                <a:cs typeface="Pretendard" pitchFamily="34" charset="-120"/>
+              </a:rPr>
+              <a:t>데이터·전처리·어휘·시퀀스 길이·학습 예산을 동일하게 고정</a:t>
             </a:r>
             <a:endParaRPr lang="en-US" sz="1650" dirty="0"/>
           </a:p>
           <a:p>
-            <a:pPr lvl="1" indent="0" marL="0">
-              <a:buNone/>
-            </a:pPr>
-            <a:r>
-              <a:rPr lang="en-US" sz="1250" dirty="0">
-                <a:solidFill>
-                  <a:srgbClr val="1D4ED8"/>
-                </a:solidFill>
-                <a:latin typeface="Pretendard" pitchFamily="34" charset="0"/>
-                <a:ea typeface="Pretendard" pitchFamily="34" charset="-122"/>
-                <a:cs typeface="Pretendard" pitchFamily="34" charset="-120"/>
-              </a:rPr>
-              <a:t>●   </a:t>
-            </a:r>
-            <a:pPr lvl="1" indent="0" marL="0">
-              <a:lnSpc>
-                <a:spcPct val="120000"/>
+            <a:pPr lvl="1" marL="457200" indent="-228600">
+              <a:lnSpc>
+                <a:spcPct val="125000"/>
               </a:lnSpc>
               <a:spcAft>
                 <a:spcPts val="500"/>
               </a:spcAft>
-              <a:buNone/>
+              <a:buSzPct val="100000"/>
+              <a:buChar char="●"/>
             </a:pPr>
             <a:r>
               <a:rPr lang="en-US" sz="1500" dirty="0">
@@ -3231,7 +3029,7 @@
           <a:p>
             <a:pPr indent="0" marL="0">
               <a:spcBef>
-                <a:spcPts val="1800"/>
+                <a:spcPts val="1500"/>
               </a:spcBef>
               <a:spcAft>
                 <a:spcPts val="700"/>
@@ -3252,28 +3050,15 @@
             <a:endParaRPr lang="en-US" sz="1650" dirty="0"/>
           </a:p>
           <a:p>
-            <a:pPr lvl="1" indent="0" marL="0">
-              <a:buNone/>
-            </a:pPr>
-            <a:r>
-              <a:rPr lang="en-US" sz="1250" dirty="0">
-                <a:solidFill>
-                  <a:srgbClr val="1D4ED8"/>
-                </a:solidFill>
-                <a:latin typeface="Pretendard" pitchFamily="34" charset="0"/>
-                <a:ea typeface="Pretendard" pitchFamily="34" charset="-122"/>
-                <a:cs typeface="Pretendard" pitchFamily="34" charset="-120"/>
-              </a:rPr>
-              <a:t>●   </a:t>
-            </a:r>
-            <a:pPr lvl="1" indent="0" marL="0">
-              <a:lnSpc>
-                <a:spcPct val="120000"/>
+            <a:pPr lvl="1" marL="457200" indent="-228600">
+              <a:lnSpc>
+                <a:spcPct val="125000"/>
               </a:lnSpc>
               <a:spcAft>
                 <a:spcPts val="500"/>
               </a:spcAft>
-              <a:buNone/>
+              <a:buSzPct val="100000"/>
+              <a:buChar char="●"/>
             </a:pPr>
             <a:r>
               <a:rPr lang="en-US" sz="1500" dirty="0">
@@ -3289,28 +3074,15 @@
             <a:endParaRPr lang="en-US" sz="1650" dirty="0"/>
           </a:p>
           <a:p>
-            <a:pPr lvl="1" indent="0" marL="0">
-              <a:buNone/>
-            </a:pPr>
-            <a:r>
-              <a:rPr lang="en-US" sz="1250" dirty="0">
-                <a:solidFill>
-                  <a:srgbClr val="1D4ED8"/>
-                </a:solidFill>
-                <a:latin typeface="Pretendard" pitchFamily="34" charset="0"/>
-                <a:ea typeface="Pretendard" pitchFamily="34" charset="-122"/>
-                <a:cs typeface="Pretendard" pitchFamily="34" charset="-120"/>
-              </a:rPr>
-              <a:t>●   </a:t>
-            </a:r>
-            <a:pPr lvl="1" indent="0" marL="0">
-              <a:lnSpc>
-                <a:spcPct val="120000"/>
+            <a:pPr lvl="1" marL="457200" indent="-228600">
+              <a:lnSpc>
+                <a:spcPct val="125000"/>
               </a:lnSpc>
               <a:spcAft>
                 <a:spcPts val="500"/>
               </a:spcAft>
-              <a:buNone/>
+              <a:buSzPct val="100000"/>
+              <a:buChar char="●"/>
             </a:pPr>
             <a:r>
               <a:rPr lang="en-US" sz="1500" dirty="0">
@@ -3638,28 +3410,15 @@
             <a:endParaRPr lang="en-US" sz="1650" dirty="0"/>
           </a:p>
           <a:p>
-            <a:pPr lvl="1" indent="0" marL="0">
-              <a:buNone/>
-            </a:pPr>
-            <a:r>
-              <a:rPr lang="en-US" sz="1250" dirty="0">
-                <a:solidFill>
-                  <a:srgbClr val="1D4ED8"/>
-                </a:solidFill>
-                <a:latin typeface="Pretendard" pitchFamily="34" charset="0"/>
-                <a:ea typeface="Pretendard" pitchFamily="34" charset="-122"/>
-                <a:cs typeface="Pretendard" pitchFamily="34" charset="-120"/>
-              </a:rPr>
-              <a:t>●   </a:t>
-            </a:r>
-            <a:pPr lvl="1" indent="0" marL="0">
-              <a:lnSpc>
-                <a:spcPct val="120000"/>
+            <a:pPr lvl="1" marL="457200" indent="-228600">
+              <a:lnSpc>
+                <a:spcPct val="125000"/>
               </a:lnSpc>
               <a:spcAft>
                 <a:spcPts val="500"/>
               </a:spcAft>
-              <a:buNone/>
+              <a:buSzPct val="100000"/>
+              <a:buChar char="●"/>
             </a:pPr>
             <a:r>
               <a:rPr lang="en-US" sz="1500" b="1" dirty="0">
@@ -3677,7 +3436,7 @@
           <a:p>
             <a:pPr indent="0" marL="0">
               <a:spcBef>
-                <a:spcPts val="1600"/>
+                <a:spcPts val="1400"/>
               </a:spcBef>
               <a:spcAft>
                 <a:spcPts val="700"/>
@@ -3698,82 +3457,39 @@
             <a:endParaRPr lang="en-US" sz="1650" dirty="0"/>
           </a:p>
           <a:p>
-            <a:pPr lvl="1" indent="0" marL="0">
-              <a:buNone/>
-            </a:pPr>
-            <a:r>
-              <a:rPr lang="en-US" sz="1250" dirty="0">
-                <a:solidFill>
-                  <a:srgbClr val="1D4ED8"/>
-                </a:solidFill>
-                <a:latin typeface="Pretendard" pitchFamily="34" charset="0"/>
-                <a:ea typeface="Pretendard" pitchFamily="34" charset="-122"/>
-                <a:cs typeface="Pretendard" pitchFamily="34" charset="-120"/>
-              </a:rPr>
-              <a:t>●   </a:t>
-            </a:r>
-            <a:pPr lvl="1" indent="0" marL="0">
-              <a:lnSpc>
-                <a:spcPct val="120000"/>
-              </a:lnSpc>
-              <a:buNone/>
-            </a:pPr>
-            <a:r>
-              <a:rPr lang="en-US" sz="1500" b="1" dirty="0">
-                <a:solidFill>
-                  <a:srgbClr val="111827"/>
-                </a:solidFill>
-                <a:latin typeface="Pretendard" pitchFamily="34" charset="0"/>
-                <a:ea typeface="Pretendard" pitchFamily="34" charset="-122"/>
-                <a:cs typeface="Pretendard" pitchFamily="34" charset="-120"/>
-              </a:rPr>
-              <a:t>World, Sports, Business, Sci-Tech</a:t>
-            </a:r>
-            <a:pPr lvl="1" indent="0" marL="0">
-              <a:lnSpc>
-                <a:spcPct val="120000"/>
+            <a:pPr lvl="1" marL="457200" indent="-228600">
+              <a:lnSpc>
+                <a:spcPct val="125000"/>
               </a:lnSpc>
               <a:spcAft>
                 <a:spcPts val="500"/>
               </a:spcAft>
-              <a:buNone/>
-            </a:pPr>
-            <a:r>
-              <a:rPr lang="en-US" sz="1500" dirty="0">
-                <a:solidFill>
-                  <a:srgbClr val="374151"/>
-                </a:solidFill>
-                <a:latin typeface="Pretendard" pitchFamily="34" charset="0"/>
-                <a:ea typeface="Pretendard" pitchFamily="34" charset="-122"/>
-                <a:cs typeface="Pretendard" pitchFamily="34" charset="-120"/>
-              </a:rPr>
-              <a:t> 4개, balanced</a:t>
+              <a:buSzPct val="100000"/>
+              <a:buChar char="●"/>
+            </a:pPr>
+            <a:r>
+              <a:rPr lang="en-US" sz="1500" b="1" dirty="0">
+                <a:solidFill>
+                  <a:srgbClr val="111827"/>
+                </a:solidFill>
+                <a:latin typeface="Pretendard" pitchFamily="34" charset="0"/>
+                <a:ea typeface="Pretendard" pitchFamily="34" charset="-122"/>
+                <a:cs typeface="Pretendard" pitchFamily="34" charset="-120"/>
+              </a:rPr>
+              <a:t>World, Sports, Business, Sci-Tech 4개, balanced</a:t>
             </a:r>
             <a:endParaRPr lang="en-US" sz="1650" dirty="0"/>
           </a:p>
           <a:p>
-            <a:pPr lvl="1" indent="0" marL="0">
-              <a:buNone/>
-            </a:pPr>
-            <a:r>
-              <a:rPr lang="en-US" sz="1250" dirty="0">
-                <a:solidFill>
-                  <a:srgbClr val="1D4ED8"/>
-                </a:solidFill>
-                <a:latin typeface="Pretendard" pitchFamily="34" charset="0"/>
-                <a:ea typeface="Pretendard" pitchFamily="34" charset="-122"/>
-                <a:cs typeface="Pretendard" pitchFamily="34" charset="-120"/>
-              </a:rPr>
-              <a:t>●   </a:t>
-            </a:r>
-            <a:pPr lvl="1" indent="0" marL="0">
-              <a:lnSpc>
-                <a:spcPct val="120000"/>
+            <a:pPr lvl="1" marL="457200" indent="-228600">
+              <a:lnSpc>
+                <a:spcPct val="125000"/>
               </a:lnSpc>
               <a:spcAft>
                 <a:spcPts val="500"/>
               </a:spcAft>
-              <a:buNone/>
+              <a:buSzPct val="100000"/>
+              <a:buChar char="●"/>
             </a:pPr>
             <a:r>
               <a:rPr lang="en-US" sz="1500" dirty="0">
@@ -3791,7 +3507,7 @@
           <a:p>
             <a:pPr indent="0" marL="0">
               <a:spcBef>
-                <a:spcPts val="1600"/>
+                <a:spcPts val="1400"/>
               </a:spcBef>
               <a:spcAft>
                 <a:spcPts val="700"/>
@@ -3812,28 +3528,15 @@
             <a:endParaRPr lang="en-US" sz="1650" dirty="0"/>
           </a:p>
           <a:p>
-            <a:pPr lvl="1" indent="0" marL="0">
-              <a:buNone/>
-            </a:pPr>
-            <a:r>
-              <a:rPr lang="en-US" sz="1250" dirty="0">
-                <a:solidFill>
-                  <a:srgbClr val="1D4ED8"/>
-                </a:solidFill>
-                <a:latin typeface="Pretendard" pitchFamily="34" charset="0"/>
-                <a:ea typeface="Pretendard" pitchFamily="34" charset="-122"/>
-                <a:cs typeface="Pretendard" pitchFamily="34" charset="-120"/>
-              </a:rPr>
-              <a:t>●   </a:t>
-            </a:r>
-            <a:pPr lvl="1" indent="0" marL="0">
-              <a:lnSpc>
-                <a:spcPct val="120000"/>
+            <a:pPr lvl="1" marL="457200" indent="-228600">
+              <a:lnSpc>
+                <a:spcPct val="125000"/>
               </a:lnSpc>
               <a:spcAft>
                 <a:spcPts val="500"/>
               </a:spcAft>
-              <a:buNone/>
+              <a:buSzPct val="100000"/>
+              <a:buChar char="●"/>
             </a:pPr>
             <a:r>
               <a:rPr lang="en-US" sz="1500" dirty="0">
@@ -3849,28 +3552,15 @@
             <a:endParaRPr lang="en-US" sz="1650" dirty="0"/>
           </a:p>
           <a:p>
-            <a:pPr lvl="1" indent="0" marL="0">
-              <a:buNone/>
-            </a:pPr>
-            <a:r>
-              <a:rPr lang="en-US" sz="1250" dirty="0">
-                <a:solidFill>
-                  <a:srgbClr val="1D4ED8"/>
-                </a:solidFill>
-                <a:latin typeface="Pretendard" pitchFamily="34" charset="0"/>
-                <a:ea typeface="Pretendard" pitchFamily="34" charset="-122"/>
-                <a:cs typeface="Pretendard" pitchFamily="34" charset="-120"/>
-              </a:rPr>
-              <a:t>●   </a:t>
-            </a:r>
-            <a:pPr lvl="1" indent="0" marL="0">
-              <a:lnSpc>
-                <a:spcPct val="120000"/>
+            <a:pPr lvl="1" marL="457200" indent="-228600">
+              <a:lnSpc>
+                <a:spcPct val="125000"/>
               </a:lnSpc>
               <a:spcAft>
                 <a:spcPts val="500"/>
               </a:spcAft>
-              <a:buNone/>
+              <a:buSzPct val="100000"/>
+              <a:buChar char="●"/>
             </a:pPr>
             <a:r>
               <a:rPr lang="en-US" sz="1500" dirty="0">
@@ -3886,28 +3576,15 @@
             <a:endParaRPr lang="en-US" sz="1650" dirty="0"/>
           </a:p>
           <a:p>
-            <a:pPr lvl="1" indent="0" marL="0">
-              <a:buNone/>
-            </a:pPr>
-            <a:r>
-              <a:rPr lang="en-US" sz="1250" dirty="0">
-                <a:solidFill>
-                  <a:srgbClr val="1D4ED8"/>
-                </a:solidFill>
-                <a:latin typeface="Pretendard" pitchFamily="34" charset="0"/>
-                <a:ea typeface="Pretendard" pitchFamily="34" charset="-122"/>
-                <a:cs typeface="Pretendard" pitchFamily="34" charset="-120"/>
-              </a:rPr>
-              <a:t>●   </a:t>
-            </a:r>
-            <a:pPr lvl="1" indent="0" marL="0">
-              <a:lnSpc>
-                <a:spcPct val="120000"/>
+            <a:pPr lvl="1" marL="457200" indent="-228600">
+              <a:lnSpc>
+                <a:spcPct val="125000"/>
               </a:lnSpc>
               <a:spcAft>
                 <a:spcPts val="500"/>
               </a:spcAft>
-              <a:buNone/>
+              <a:buSzPct val="100000"/>
+              <a:buChar char="●"/>
             </a:pPr>
             <a:r>
               <a:rPr lang="en-US" sz="1500" dirty="0">
@@ -4218,28 +3895,15 @@
             <a:endParaRPr lang="en-US" sz="1650" dirty="0"/>
           </a:p>
           <a:p>
-            <a:pPr lvl="1" indent="0" marL="0">
-              <a:buNone/>
-            </a:pPr>
-            <a:r>
-              <a:rPr lang="en-US" sz="1250" dirty="0">
-                <a:solidFill>
-                  <a:srgbClr val="1D4ED8"/>
-                </a:solidFill>
-                <a:latin typeface="Pretendard" pitchFamily="34" charset="0"/>
-                <a:ea typeface="Pretendard" pitchFamily="34" charset="-122"/>
-                <a:cs typeface="Pretendard" pitchFamily="34" charset="-120"/>
-              </a:rPr>
-              <a:t>●   </a:t>
-            </a:r>
-            <a:pPr lvl="1" indent="0" marL="0">
-              <a:lnSpc>
-                <a:spcPct val="120000"/>
+            <a:pPr lvl="1" marL="457200" indent="-228600">
+              <a:lnSpc>
+                <a:spcPct val="125000"/>
               </a:lnSpc>
               <a:spcAft>
                 <a:spcPts val="500"/>
               </a:spcAft>
-              <a:buNone/>
+              <a:buSzPct val="100000"/>
+              <a:buChar char="●"/>
             </a:pPr>
             <a:r>
               <a:rPr lang="en-US" sz="1500" b="1" dirty="0">
@@ -4255,28 +3919,15 @@
             <a:endParaRPr lang="en-US" sz="1650" dirty="0"/>
           </a:p>
           <a:p>
-            <a:pPr lvl="1" indent="0" marL="0">
-              <a:buNone/>
-            </a:pPr>
-            <a:r>
-              <a:rPr lang="en-US" sz="1250" dirty="0">
-                <a:solidFill>
-                  <a:srgbClr val="1D4ED8"/>
-                </a:solidFill>
-                <a:latin typeface="Pretendard" pitchFamily="34" charset="0"/>
-                <a:ea typeface="Pretendard" pitchFamily="34" charset="-122"/>
-                <a:cs typeface="Pretendard" pitchFamily="34" charset="-120"/>
-              </a:rPr>
-              <a:t>●   </a:t>
-            </a:r>
-            <a:pPr lvl="1" indent="0" marL="0">
-              <a:lnSpc>
-                <a:spcPct val="120000"/>
+            <a:pPr lvl="1" marL="457200" indent="-228600">
+              <a:lnSpc>
+                <a:spcPct val="125000"/>
               </a:lnSpc>
               <a:spcAft>
                 <a:spcPts val="500"/>
               </a:spcAft>
-              <a:buNone/>
+              <a:buSzPct val="100000"/>
+              <a:buChar char="●"/>
             </a:pPr>
             <a:r>
               <a:rPr lang="en-US" sz="1500" dirty="0">
@@ -4294,7 +3945,7 @@
           <a:p>
             <a:pPr indent="0" marL="0">
               <a:spcBef>
-                <a:spcPts val="1700"/>
+                <a:spcPts val="1500"/>
               </a:spcBef>
               <a:spcAft>
                 <a:spcPts val="700"/>
@@ -4315,45 +3966,15 @@
             <a:endParaRPr lang="en-US" sz="1650" dirty="0"/>
           </a:p>
           <a:p>
-            <a:pPr lvl="1" indent="0" marL="0">
-              <a:buNone/>
-            </a:pPr>
-            <a:r>
-              <a:rPr lang="en-US" sz="1250" dirty="0">
-                <a:solidFill>
-                  <a:srgbClr val="1D4ED8"/>
-                </a:solidFill>
-                <a:latin typeface="Pretendard" pitchFamily="34" charset="0"/>
-                <a:ea typeface="Pretendard" pitchFamily="34" charset="-122"/>
-                <a:cs typeface="Pretendard" pitchFamily="34" charset="-120"/>
-              </a:rPr>
-              <a:t>●   </a:t>
-            </a:r>
-            <a:pPr lvl="1" indent="0" marL="0">
-              <a:lnSpc>
-                <a:spcPct val="120000"/>
-              </a:lnSpc>
-              <a:buNone/>
-            </a:pPr>
-            <a:r>
-              <a:rPr lang="en-US" sz="1500" b="1" dirty="0">
-                <a:solidFill>
-                  <a:srgbClr val="111827"/>
-                </a:solidFill>
-                <a:latin typeface="Pretendard" pitchFamily="34" charset="0"/>
-                <a:ea typeface="Pretendard" pitchFamily="34" charset="-122"/>
-                <a:cs typeface="Pretendard" pitchFamily="34" charset="-120"/>
-              </a:rPr>
-              <a:t>LSTM   </a:t>
-            </a:r>
-            <a:pPr lvl="1" indent="0" marL="0">
-              <a:lnSpc>
-                <a:spcPct val="120000"/>
+            <a:pPr lvl="1" marL="457200" indent="-228600">
+              <a:lnSpc>
+                <a:spcPct val="125000"/>
               </a:lnSpc>
               <a:spcAft>
                 <a:spcPts val="500"/>
               </a:spcAft>
-              <a:buNone/>
+              <a:buSzPct val="100000"/>
+              <a:buChar char="●"/>
             </a:pPr>
             <a:r>
               <a:rPr lang="en-US" sz="1500" dirty="0">
@@ -4364,50 +3985,20 @@
                 <a:ea typeface="Pretendard" pitchFamily="34" charset="-122"/>
                 <a:cs typeface="Pretendard" pitchFamily="34" charset="-120"/>
               </a:rPr>
-              <a:t>bidirectional · 2 layers · hidden 128 / output 256 / params 3,220,484</a:t>
+              <a:t>LSTM : bidirectional · 2 layers · hidden 128 / output 256 / params 3,220,484</a:t>
             </a:r>
             <a:endParaRPr lang="en-US" sz="1650" dirty="0"/>
           </a:p>
           <a:p>
-            <a:pPr lvl="1" indent="0" marL="0">
-              <a:buNone/>
-            </a:pPr>
-            <a:r>
-              <a:rPr lang="en-US" sz="1250" dirty="0">
-                <a:solidFill>
-                  <a:srgbClr val="1D4ED8"/>
-                </a:solidFill>
-                <a:latin typeface="Pretendard" pitchFamily="34" charset="0"/>
-                <a:ea typeface="Pretendard" pitchFamily="34" charset="-122"/>
-                <a:cs typeface="Pretendard" pitchFamily="34" charset="-120"/>
-              </a:rPr>
-              <a:t>●   </a:t>
-            </a:r>
-            <a:pPr lvl="1" indent="0" marL="0">
-              <a:lnSpc>
-                <a:spcPct val="120000"/>
-              </a:lnSpc>
-              <a:buNone/>
-            </a:pPr>
-            <a:r>
-              <a:rPr lang="en-US" sz="1500" b="1" dirty="0">
-                <a:solidFill>
-                  <a:srgbClr val="111827"/>
-                </a:solidFill>
-                <a:latin typeface="Pretendard" pitchFamily="34" charset="0"/>
-                <a:ea typeface="Pretendard" pitchFamily="34" charset="-122"/>
-                <a:cs typeface="Pretendard" pitchFamily="34" charset="-120"/>
-              </a:rPr>
-              <a:t>Transformer   </a:t>
-            </a:r>
-            <a:pPr lvl="1" indent="0" marL="0">
-              <a:lnSpc>
-                <a:spcPct val="120000"/>
+            <a:pPr lvl="1" marL="457200" indent="-228600">
+              <a:lnSpc>
+                <a:spcPct val="125000"/>
               </a:lnSpc>
               <a:spcAft>
                 <a:spcPts val="500"/>
               </a:spcAft>
-              <a:buNone/>
+              <a:buSzPct val="100000"/>
+              <a:buChar char="●"/>
             </a:pPr>
             <a:r>
               <a:rPr lang="en-US" sz="1500" dirty="0">
@@ -4418,14 +4009,14 @@
                 <a:ea typeface="Pretendard" pitchFamily="34" charset="-122"/>
                 <a:cs typeface="Pretendard" pitchFamily="34" charset="-120"/>
               </a:rPr>
-              <a:t>2 layers · 4 heads · FFN 256 · sinusoidal PE / dim 128 / params 2,825,476</a:t>
+              <a:t>Transformer : 2 layers · 4 heads · FFN 256 · sinusoidal PE / dim 128 / params 2,825,476</a:t>
             </a:r>
             <a:endParaRPr lang="en-US" sz="1650" dirty="0"/>
           </a:p>
           <a:p>
             <a:pPr indent="0" marL="0">
               <a:spcBef>
-                <a:spcPts val="1700"/>
+                <a:spcPts val="1500"/>
               </a:spcBef>
               <a:spcAft>
                 <a:spcPts val="700"/>
@@ -4446,28 +4037,15 @@
             <a:endParaRPr lang="en-US" sz="1650" dirty="0"/>
           </a:p>
           <a:p>
-            <a:pPr lvl="1" indent="0" marL="0">
-              <a:buNone/>
-            </a:pPr>
-            <a:r>
-              <a:rPr lang="en-US" sz="1250" dirty="0">
-                <a:solidFill>
-                  <a:srgbClr val="1D4ED8"/>
-                </a:solidFill>
-                <a:latin typeface="Pretendard" pitchFamily="34" charset="0"/>
-                <a:ea typeface="Pretendard" pitchFamily="34" charset="-122"/>
-                <a:cs typeface="Pretendard" pitchFamily="34" charset="-120"/>
-              </a:rPr>
-              <a:t>●   </a:t>
-            </a:r>
-            <a:pPr lvl="1" indent="0" marL="0">
-              <a:lnSpc>
-                <a:spcPct val="120000"/>
+            <a:pPr lvl="1" marL="457200" indent="-228600">
+              <a:lnSpc>
+                <a:spcPct val="125000"/>
               </a:lnSpc>
               <a:spcAft>
                 <a:spcPts val="500"/>
               </a:spcAft>
-              <a:buNone/>
+              <a:buSzPct val="100000"/>
+              <a:buChar char="●"/>
             </a:pPr>
             <a:r>
               <a:rPr lang="en-US" sz="1500" dirty="0">
@@ -4795,28 +4373,15 @@
             <a:endParaRPr lang="en-US" sz="1650" dirty="0"/>
           </a:p>
           <a:p>
-            <a:pPr lvl="1" indent="0" marL="0">
-              <a:buNone/>
-            </a:pPr>
-            <a:r>
-              <a:rPr lang="en-US" sz="1250" dirty="0">
-                <a:solidFill>
-                  <a:srgbClr val="1D4ED8"/>
-                </a:solidFill>
-                <a:latin typeface="Pretendard" pitchFamily="34" charset="0"/>
-                <a:ea typeface="Pretendard" pitchFamily="34" charset="-122"/>
-                <a:cs typeface="Pretendard" pitchFamily="34" charset="-120"/>
-              </a:rPr>
-              <a:t>●   </a:t>
-            </a:r>
-            <a:pPr lvl="1" indent="0" marL="0">
-              <a:lnSpc>
-                <a:spcPct val="120000"/>
+            <a:pPr lvl="1" marL="457200" indent="-228600">
+              <a:lnSpc>
+                <a:spcPct val="125000"/>
               </a:lnSpc>
               <a:spcAft>
                 <a:spcPts val="500"/>
               </a:spcAft>
-              <a:buNone/>
+              <a:buSzPct val="100000"/>
+              <a:buChar char="●"/>
             </a:pPr>
             <a:r>
               <a:rPr lang="en-US" sz="1500" dirty="0">
@@ -4832,28 +4397,15 @@
             <a:endParaRPr lang="en-US" sz="1650" dirty="0"/>
           </a:p>
           <a:p>
-            <a:pPr lvl="1" indent="0" marL="0">
-              <a:buNone/>
-            </a:pPr>
-            <a:r>
-              <a:rPr lang="en-US" sz="1250" dirty="0">
-                <a:solidFill>
-                  <a:srgbClr val="1D4ED8"/>
-                </a:solidFill>
-                <a:latin typeface="Pretendard" pitchFamily="34" charset="0"/>
-                <a:ea typeface="Pretendard" pitchFamily="34" charset="-122"/>
-                <a:cs typeface="Pretendard" pitchFamily="34" charset="-120"/>
-              </a:rPr>
-              <a:t>●   </a:t>
-            </a:r>
-            <a:pPr lvl="1" indent="0" marL="0">
-              <a:lnSpc>
-                <a:spcPct val="120000"/>
+            <a:pPr lvl="1" marL="457200" indent="-228600">
+              <a:lnSpc>
+                <a:spcPct val="125000"/>
               </a:lnSpc>
               <a:spcAft>
                 <a:spcPts val="500"/>
               </a:spcAft>
-              <a:buNone/>
+              <a:buSzPct val="100000"/>
+              <a:buChar char="●"/>
             </a:pPr>
             <a:r>
               <a:rPr lang="en-US" sz="1500" dirty="0">
@@ -4871,7 +4423,7 @@
           <a:p>
             <a:pPr indent="0" marL="0">
               <a:spcBef>
-                <a:spcPts val="1600"/>
+                <a:spcPts val="1400"/>
               </a:spcBef>
               <a:spcAft>
                 <a:spcPts val="700"/>
@@ -4892,28 +4444,15 @@
             <a:endParaRPr lang="en-US" sz="1650" dirty="0"/>
           </a:p>
           <a:p>
-            <a:pPr lvl="1" indent="0" marL="0">
-              <a:buNone/>
-            </a:pPr>
-            <a:r>
-              <a:rPr lang="en-US" sz="1250" dirty="0">
-                <a:solidFill>
-                  <a:srgbClr val="1D4ED8"/>
-                </a:solidFill>
-                <a:latin typeface="Pretendard" pitchFamily="34" charset="0"/>
-                <a:ea typeface="Pretendard" pitchFamily="34" charset="-122"/>
-                <a:cs typeface="Pretendard" pitchFamily="34" charset="-120"/>
-              </a:rPr>
-              <a:t>●   </a:t>
-            </a:r>
-            <a:pPr lvl="1" indent="0" marL="0">
-              <a:lnSpc>
-                <a:spcPct val="120000"/>
+            <a:pPr lvl="1" marL="457200" indent="-228600">
+              <a:lnSpc>
+                <a:spcPct val="125000"/>
               </a:lnSpc>
               <a:spcAft>
                 <a:spcPts val="500"/>
               </a:spcAft>
-              <a:buNone/>
+              <a:buSzPct val="100000"/>
+              <a:buChar char="●"/>
             </a:pPr>
             <a:r>
               <a:rPr lang="en-US" sz="1500" dirty="0">
@@ -4929,28 +4468,15 @@
             <a:endParaRPr lang="en-US" sz="1650" dirty="0"/>
           </a:p>
           <a:p>
-            <a:pPr lvl="1" indent="0" marL="0">
-              <a:buNone/>
-            </a:pPr>
-            <a:r>
-              <a:rPr lang="en-US" sz="1250" dirty="0">
-                <a:solidFill>
-                  <a:srgbClr val="1D4ED8"/>
-                </a:solidFill>
-                <a:latin typeface="Pretendard" pitchFamily="34" charset="0"/>
-                <a:ea typeface="Pretendard" pitchFamily="34" charset="-122"/>
-                <a:cs typeface="Pretendard" pitchFamily="34" charset="-120"/>
-              </a:rPr>
-              <a:t>●   </a:t>
-            </a:r>
-            <a:pPr lvl="1" indent="0" marL="0">
-              <a:lnSpc>
-                <a:spcPct val="120000"/>
+            <a:pPr lvl="1" marL="457200" indent="-228600">
+              <a:lnSpc>
+                <a:spcPct val="125000"/>
               </a:lnSpc>
               <a:spcAft>
                 <a:spcPts val="500"/>
               </a:spcAft>
-              <a:buNone/>
+              <a:buSzPct val="100000"/>
+              <a:buChar char="●"/>
             </a:pPr>
             <a:r>
               <a:rPr lang="en-US" sz="1500" dirty="0">
@@ -4968,7 +4494,7 @@
           <a:p>
             <a:pPr indent="0" marL="0">
               <a:spcBef>
-                <a:spcPts val="1600"/>
+                <a:spcPts val="1400"/>
               </a:spcBef>
               <a:spcAft>
                 <a:spcPts val="700"/>
@@ -4989,82 +4515,39 @@
             <a:endParaRPr lang="en-US" sz="1650" dirty="0"/>
           </a:p>
           <a:p>
-            <a:pPr lvl="1" indent="0" marL="0">
-              <a:buNone/>
-            </a:pPr>
-            <a:r>
-              <a:rPr lang="en-US" sz="1250" dirty="0">
-                <a:solidFill>
-                  <a:srgbClr val="1D4ED8"/>
-                </a:solidFill>
-                <a:latin typeface="Pretendard" pitchFamily="34" charset="0"/>
-                <a:ea typeface="Pretendard" pitchFamily="34" charset="-122"/>
-                <a:cs typeface="Pretendard" pitchFamily="34" charset="-120"/>
-              </a:rPr>
-              <a:t>●   </a:t>
-            </a:r>
-            <a:pPr lvl="1" indent="0" marL="0">
-              <a:lnSpc>
-                <a:spcPct val="120000"/>
-              </a:lnSpc>
-              <a:buNone/>
-            </a:pPr>
-            <a:r>
-              <a:rPr lang="en-US" sz="1500" b="1" dirty="0">
-                <a:solidFill>
-                  <a:srgbClr val="111827"/>
-                </a:solidFill>
-                <a:latin typeface="Pretendard" pitchFamily="34" charset="0"/>
-                <a:ea typeface="Pretendard" pitchFamily="34" charset="-122"/>
-                <a:cs typeface="Pretendard" pitchFamily="34" charset="-120"/>
-              </a:rPr>
-              <a:t>training set 5 / 25 / 50 / 100%</a:t>
-            </a:r>
-            <a:pPr lvl="1" indent="0" marL="0">
-              <a:lnSpc>
-                <a:spcPct val="120000"/>
+            <a:pPr lvl="1" marL="457200" indent="-228600">
+              <a:lnSpc>
+                <a:spcPct val="125000"/>
               </a:lnSpc>
               <a:spcAft>
                 <a:spcPts val="500"/>
               </a:spcAft>
-              <a:buNone/>
-            </a:pPr>
-            <a:r>
-              <a:rPr lang="en-US" sz="1500" dirty="0">
-                <a:solidFill>
-                  <a:srgbClr val="374151"/>
-                </a:solidFill>
-                <a:latin typeface="Pretendard" pitchFamily="34" charset="0"/>
-                <a:ea typeface="Pretendard" pitchFamily="34" charset="-122"/>
-                <a:cs typeface="Pretendard" pitchFamily="34" charset="-120"/>
-              </a:rPr>
-              <a:t> (vocabulary 고정, stratified, val·test 전체)</a:t>
+              <a:buSzPct val="100000"/>
+              <a:buChar char="●"/>
+            </a:pPr>
+            <a:r>
+              <a:rPr lang="en-US" sz="1500" b="1" dirty="0">
+                <a:solidFill>
+                  <a:srgbClr val="111827"/>
+                </a:solidFill>
+                <a:latin typeface="Pretendard" pitchFamily="34" charset="0"/>
+                <a:ea typeface="Pretendard" pitchFamily="34" charset="-122"/>
+                <a:cs typeface="Pretendard" pitchFamily="34" charset="-120"/>
+              </a:rPr>
+              <a:t>training set 5 / 25 / 50 / 100% (vocabulary 고정, stratified, val·test 전체)</a:t>
             </a:r>
             <a:endParaRPr lang="en-US" sz="1650" dirty="0"/>
           </a:p>
           <a:p>
-            <a:pPr lvl="1" indent="0" marL="0">
-              <a:buNone/>
-            </a:pPr>
-            <a:r>
-              <a:rPr lang="en-US" sz="1250" dirty="0">
-                <a:solidFill>
-                  <a:srgbClr val="1D4ED8"/>
-                </a:solidFill>
-                <a:latin typeface="Pretendard" pitchFamily="34" charset="0"/>
-                <a:ea typeface="Pretendard" pitchFamily="34" charset="-122"/>
-                <a:cs typeface="Pretendard" pitchFamily="34" charset="-120"/>
-              </a:rPr>
-              <a:t>●   </a:t>
-            </a:r>
-            <a:pPr lvl="1" indent="0" marL="0">
-              <a:lnSpc>
-                <a:spcPct val="120000"/>
+            <a:pPr lvl="1" marL="457200" indent="-228600">
+              <a:lnSpc>
+                <a:spcPct val="125000"/>
               </a:lnSpc>
               <a:spcAft>
                 <a:spcPts val="500"/>
               </a:spcAft>
-              <a:buNone/>
+              <a:buSzPct val="100000"/>
+              <a:buChar char="●"/>
             </a:pPr>
             <a:r>
               <a:rPr lang="en-US" sz="1500" dirty="0">
@@ -5429,65 +4912,18 @@
           <a:bodyPr wrap="square" lIns="0" tIns="0" rIns="0" bIns="0" rtlCol="0" anchor="t"/>
           <a:lstStyle/>
           <a:p>
-            <a:pPr lvl="1" indent="0" marL="0">
-              <a:buNone/>
-            </a:pPr>
-            <a:r>
-              <a:rPr lang="en-US" sz="1150" dirty="0">
-                <a:solidFill>
-                  <a:srgbClr val="1D4ED8"/>
-                </a:solidFill>
-                <a:latin typeface="Pretendard" pitchFamily="34" charset="0"/>
-                <a:ea typeface="Pretendard" pitchFamily="34" charset="-122"/>
-                <a:cs typeface="Pretendard" pitchFamily="34" charset="-120"/>
-              </a:rPr>
-              <a:t>●   </a:t>
-            </a:r>
-            <a:pPr lvl="1" indent="0" marL="0">
-              <a:lnSpc>
-                <a:spcPct val="120000"/>
-              </a:lnSpc>
-              <a:buNone/>
-            </a:pPr>
-            <a:r>
-              <a:rPr lang="en-US" sz="1400" b="1" dirty="0">
-                <a:solidFill>
-                  <a:srgbClr val="1D4ED8"/>
-                </a:solidFill>
-                <a:latin typeface="Pretendard" pitchFamily="34" charset="0"/>
-                <a:ea typeface="Pretendard" pitchFamily="34" charset="-122"/>
-                <a:cs typeface="Pretendard" pitchFamily="34" charset="-120"/>
-              </a:rPr>
-              <a:t>Transformer   </a:t>
-            </a:r>
-            <a:pPr lvl="1" indent="0" marL="0">
-              <a:lnSpc>
-                <a:spcPct val="120000"/>
+            <a:pPr lvl="1" marL="457200" indent="-228600">
+              <a:lnSpc>
+                <a:spcPct val="125000"/>
               </a:lnSpc>
               <a:spcAft>
                 <a:spcPts val="500"/>
               </a:spcAft>
-              <a:buNone/>
-            </a:pPr>
-            <a:r>
-              <a:rPr lang="en-US" sz="1400" dirty="0">
-                <a:solidFill>
-                  <a:srgbClr val="374151"/>
-                </a:solidFill>
-                <a:latin typeface="Pretendard" pitchFamily="34" charset="0"/>
-                <a:ea typeface="Pretendard" pitchFamily="34" charset="-122"/>
-                <a:cs typeface="Pretendard" pitchFamily="34" charset="-120"/>
-              </a:rPr>
-              <a:t>test accuracy 0.910 · macro F1 0.909</a:t>
-            </a:r>
-            <a:endParaRPr lang="en-US" sz="1150" dirty="0"/>
-          </a:p>
-          <a:p>
-            <a:pPr lvl="1" indent="0" marL="0">
-              <a:buNone/>
-            </a:pPr>
-            <a:r>
-              <a:rPr lang="en-US" sz="1150" dirty="0">
+              <a:buSzPct val="100000"/>
+              <a:buChar char="●"/>
+            </a:pPr>
+            <a:r>
+              <a:rPr lang="en-US" sz="1400" b="1" dirty="0">
                 <a:solidFill>
                   <a:srgbClr val="1D4ED8"/>
                 </a:solidFill>
@@ -5495,33 +4931,20 @@
                 <a:ea typeface="Pretendard" pitchFamily="34" charset="-122"/>
                 <a:cs typeface="Pretendard" pitchFamily="34" charset="-120"/>
               </a:rPr>
-              <a:t>●   </a:t>
-            </a:r>
-            <a:pPr lvl="1" indent="0" marL="0">
-              <a:lnSpc>
-                <a:spcPct val="120000"/>
-              </a:lnSpc>
-              <a:buNone/>
-            </a:pPr>
-            <a:r>
-              <a:rPr lang="en-US" sz="1400" b="1" dirty="0">
-                <a:solidFill>
-                  <a:srgbClr val="6B7280"/>
-                </a:solidFill>
-                <a:latin typeface="Pretendard" pitchFamily="34" charset="0"/>
-                <a:ea typeface="Pretendard" pitchFamily="34" charset="-122"/>
-                <a:cs typeface="Pretendard" pitchFamily="34" charset="-120"/>
-              </a:rPr>
-              <a:t>LSTM   </a:t>
-            </a:r>
-            <a:pPr lvl="1" indent="0" marL="0">
-              <a:lnSpc>
-                <a:spcPct val="120000"/>
+              <a:t>Transformer : test accuracy 0.910 · macro F1 0.909</a:t>
+            </a:r>
+            <a:endParaRPr lang="en-US" sz="1400" dirty="0"/>
+          </a:p>
+          <a:p>
+            <a:pPr lvl="1" marL="457200" indent="-228600">
+              <a:lnSpc>
+                <a:spcPct val="125000"/>
               </a:lnSpc>
               <a:spcAft>
                 <a:spcPts val="500"/>
               </a:spcAft>
-              <a:buNone/>
+              <a:buSzPct val="100000"/>
+              <a:buChar char="●"/>
             </a:pPr>
             <a:r>
               <a:rPr lang="en-US" sz="1400" dirty="0">
@@ -5532,9 +4955,9 @@
                 <a:ea typeface="Pretendard" pitchFamily="34" charset="-122"/>
                 <a:cs typeface="Pretendard" pitchFamily="34" charset="-120"/>
               </a:rPr>
-              <a:t>0.833 · macro F1 0.835, val loss 폭증으로 best epoch 2 저장</a:t>
-            </a:r>
-            <a:endParaRPr lang="en-US" sz="1150" dirty="0"/>
+              <a:t>LSTM : 0.833 · macro F1 0.835, val loss 폭증으로 best epoch 2 저장</a:t>
+            </a:r>
+            <a:endParaRPr lang="en-US" sz="1400" dirty="0"/>
           </a:p>
         </p:txBody>
       </p:sp>
@@ -5835,79 +5258,15 @@
           <a:bodyPr wrap="square" lIns="0" tIns="0" rIns="0" bIns="0" rtlCol="0" anchor="t"/>
           <a:lstStyle/>
           <a:p>
-            <a:pPr lvl="1" indent="0" marL="0">
-              <a:buNone/>
-            </a:pPr>
-            <a:r>
-              <a:rPr lang="en-US" sz="1150" dirty="0">
-                <a:solidFill>
-                  <a:srgbClr val="1D4ED8"/>
-                </a:solidFill>
-                <a:latin typeface="Pretendard" pitchFamily="34" charset="0"/>
-                <a:ea typeface="Pretendard" pitchFamily="34" charset="-122"/>
-                <a:cs typeface="Pretendard" pitchFamily="34" charset="-120"/>
-              </a:rPr>
-              <a:t>●   </a:t>
-            </a:r>
-            <a:pPr lvl="1" indent="0" marL="0">
-              <a:lnSpc>
-                <a:spcPct val="120000"/>
-              </a:lnSpc>
-              <a:buNone/>
-            </a:pPr>
-            <a:r>
-              <a:rPr lang="en-US" sz="1400" b="1" dirty="0">
-                <a:solidFill>
-                  <a:srgbClr val="111827"/>
-                </a:solidFill>
-                <a:latin typeface="Pretendard" pitchFamily="34" charset="0"/>
-                <a:ea typeface="Pretendard" pitchFamily="34" charset="-122"/>
-                <a:cs typeface="Pretendard" pitchFamily="34" charset="-120"/>
-              </a:rPr>
-              <a:t>공통 오답 428건   </a:t>
-            </a:r>
-            <a:pPr lvl="1" indent="0" marL="0">
-              <a:lnSpc>
-                <a:spcPct val="120000"/>
+            <a:pPr lvl="1" marL="457200" indent="-228600">
+              <a:lnSpc>
+                <a:spcPct val="125000"/>
               </a:lnSpc>
               <a:spcAft>
                 <a:spcPts val="500"/>
               </a:spcAft>
-              <a:buNone/>
-            </a:pPr>
-            <a:r>
-              <a:rPr lang="en-US" sz="1400" dirty="0">
-                <a:solidFill>
-                  <a:srgbClr val="374151"/>
-                </a:solidFill>
-                <a:latin typeface="Pretendard" pitchFamily="34" charset="0"/>
-                <a:ea typeface="Pretendard" pitchFamily="34" charset="-122"/>
-                <a:cs typeface="Pretendard" pitchFamily="34" charset="-120"/>
-              </a:rPr>
-              <a:t>61%가 Business/Sci-Tech 경계 (의미 중첩에 따른 모호성)</a:t>
-            </a:r>
-            <a:endParaRPr lang="en-US" sz="1150" dirty="0"/>
-          </a:p>
-          <a:p>
-            <a:pPr lvl="1" indent="0" marL="0">
-              <a:buNone/>
-            </a:pPr>
-            <a:r>
-              <a:rPr lang="en-US" sz="1150" dirty="0">
-                <a:solidFill>
-                  <a:srgbClr val="1D4ED8"/>
-                </a:solidFill>
-                <a:latin typeface="Pretendard" pitchFamily="34" charset="0"/>
-                <a:ea typeface="Pretendard" pitchFamily="34" charset="-122"/>
-                <a:cs typeface="Pretendard" pitchFamily="34" charset="-120"/>
-              </a:rPr>
-              <a:t>●   </a:t>
-            </a:r>
-            <a:pPr lvl="1" indent="0" marL="0">
-              <a:lnSpc>
-                <a:spcPct val="120000"/>
-              </a:lnSpc>
-              <a:buNone/>
+              <a:buSzPct val="100000"/>
+              <a:buChar char="●"/>
             </a:pPr>
             <a:r>
               <a:rPr lang="en-US" sz="1400" b="1" dirty="0">
@@ -5918,16 +5277,20 @@
                 <a:ea typeface="Pretendard" pitchFamily="34" charset="-122"/>
                 <a:cs typeface="Pretendard" pitchFamily="34" charset="-120"/>
               </a:rPr>
-              <a:t>LSTM 단독 841건   </a:t>
-            </a:r>
-            <a:pPr lvl="1" indent="0" marL="0">
-              <a:lnSpc>
-                <a:spcPct val="120000"/>
+              <a:t>공통 오답 428건 : 61%가 Business/Sci-Tech 경계 (의미 중첩에 따른 모호성)</a:t>
+            </a:r>
+            <a:endParaRPr lang="en-US" sz="1400" dirty="0"/>
+          </a:p>
+          <a:p>
+            <a:pPr lvl="1" marL="457200" indent="-228600">
+              <a:lnSpc>
+                <a:spcPct val="125000"/>
               </a:lnSpc>
               <a:spcAft>
                 <a:spcPts val="500"/>
               </a:spcAft>
-              <a:buNone/>
+              <a:buSzPct val="100000"/>
+              <a:buChar char="●"/>
             </a:pPr>
             <a:r>
               <a:rPr lang="en-US" sz="1400" dirty="0">
@@ -5938,9 +5301,9 @@
                 <a:ea typeface="Pretendard" pitchFamily="34" charset="-122"/>
                 <a:cs typeface="Pretendard" pitchFamily="34" charset="-120"/>
               </a:rPr>
-              <a:t>전 class에 분산, Transformer 단독(259건)의 3.2배</a:t>
-            </a:r>
-            <a:endParaRPr lang="en-US" sz="1150" dirty="0"/>
+              <a:t>LSTM 단독 841건 : 전 class에 분산, Transformer 단독(259건)의 3.2배</a:t>
+            </a:r>
+            <a:endParaRPr lang="en-US" sz="1400" dirty="0"/>
           </a:p>
         </p:txBody>
       </p:sp>
@@ -6295,28 +5658,15 @@
             <a:endParaRPr lang="en-US" sz="1550" dirty="0"/>
           </a:p>
           <a:p>
-            <a:pPr lvl="1" indent="0" marL="0">
-              <a:buNone/>
-            </a:pPr>
-            <a:r>
-              <a:rPr lang="en-US" sz="1150" dirty="0">
-                <a:solidFill>
-                  <a:srgbClr val="1D4ED8"/>
-                </a:solidFill>
-                <a:latin typeface="Pretendard" pitchFamily="34" charset="0"/>
-                <a:ea typeface="Pretendard" pitchFamily="34" charset="-122"/>
-                <a:cs typeface="Pretendard" pitchFamily="34" charset="-120"/>
-              </a:rPr>
-              <a:t>●   </a:t>
-            </a:r>
-            <a:pPr lvl="1" indent="0" marL="0">
-              <a:lnSpc>
-                <a:spcPct val="120000"/>
+            <a:pPr lvl="1" marL="457200" indent="-228600">
+              <a:lnSpc>
+                <a:spcPct val="125000"/>
               </a:lnSpc>
               <a:spcAft>
                 <a:spcPts val="500"/>
               </a:spcAft>
-              <a:buNone/>
+              <a:buSzPct val="100000"/>
+              <a:buChar char="●"/>
             </a:pPr>
             <a:r>
               <a:rPr lang="en-US" sz="1400" b="1" dirty="0">
@@ -6332,28 +5682,15 @@
             <a:endParaRPr lang="en-US" sz="1550" dirty="0"/>
           </a:p>
           <a:p>
-            <a:pPr lvl="1" indent="0" marL="0">
-              <a:buNone/>
-            </a:pPr>
-            <a:r>
-              <a:rPr lang="en-US" sz="1150" dirty="0">
-                <a:solidFill>
-                  <a:srgbClr val="1D4ED8"/>
-                </a:solidFill>
-                <a:latin typeface="Pretendard" pitchFamily="34" charset="0"/>
-                <a:ea typeface="Pretendard" pitchFamily="34" charset="-122"/>
-                <a:cs typeface="Pretendard" pitchFamily="34" charset="-120"/>
-              </a:rPr>
-              <a:t>●   </a:t>
-            </a:r>
-            <a:pPr lvl="1" indent="0" marL="0">
-              <a:lnSpc>
-                <a:spcPct val="120000"/>
+            <a:pPr lvl="1" marL="457200" indent="-228600">
+              <a:lnSpc>
+                <a:spcPct val="125000"/>
               </a:lnSpc>
               <a:spcAft>
                 <a:spcPts val="500"/>
               </a:spcAft>
-              <a:buNone/>
+              <a:buSzPct val="100000"/>
+              <a:buChar char="●"/>
             </a:pPr>
             <a:r>
               <a:rPr lang="en-US" sz="1400" dirty="0">
@@ -6392,28 +5729,15 @@
             <a:endParaRPr lang="en-US" sz="1550" dirty="0"/>
           </a:p>
           <a:p>
-            <a:pPr lvl="1" indent="0" marL="0">
-              <a:buNone/>
-            </a:pPr>
-            <a:r>
-              <a:rPr lang="en-US" sz="1150" dirty="0">
-                <a:solidFill>
-                  <a:srgbClr val="1D4ED8"/>
-                </a:solidFill>
-                <a:latin typeface="Pretendard" pitchFamily="34" charset="0"/>
-                <a:ea typeface="Pretendard" pitchFamily="34" charset="-122"/>
-                <a:cs typeface="Pretendard" pitchFamily="34" charset="-120"/>
-              </a:rPr>
-              <a:t>●   </a:t>
-            </a:r>
-            <a:pPr lvl="1" indent="0" marL="0">
-              <a:lnSpc>
-                <a:spcPct val="120000"/>
+            <a:pPr lvl="1" marL="457200" indent="-228600">
+              <a:lnSpc>
+                <a:spcPct val="125000"/>
               </a:lnSpc>
               <a:spcAft>
                 <a:spcPts val="500"/>
               </a:spcAft>
-              <a:buNone/>
+              <a:buSzPct val="100000"/>
+              <a:buChar char="●"/>
             </a:pPr>
             <a:r>
               <a:rPr lang="en-US" sz="1400" b="1" dirty="0">
@@ -6429,28 +5753,15 @@
             <a:endParaRPr lang="en-US" sz="1550" dirty="0"/>
           </a:p>
           <a:p>
-            <a:pPr lvl="1" indent="0" marL="0">
-              <a:buNone/>
-            </a:pPr>
-            <a:r>
-              <a:rPr lang="en-US" sz="1150" dirty="0">
-                <a:solidFill>
-                  <a:srgbClr val="1D4ED8"/>
-                </a:solidFill>
-                <a:latin typeface="Pretendard" pitchFamily="34" charset="0"/>
-                <a:ea typeface="Pretendard" pitchFamily="34" charset="-122"/>
-                <a:cs typeface="Pretendard" pitchFamily="34" charset="-120"/>
-              </a:rPr>
-              <a:t>●   </a:t>
-            </a:r>
-            <a:pPr lvl="1" indent="0" marL="0">
-              <a:lnSpc>
-                <a:spcPct val="120000"/>
+            <a:pPr lvl="1" marL="457200" indent="-228600">
+              <a:lnSpc>
+                <a:spcPct val="125000"/>
               </a:lnSpc>
               <a:spcAft>
                 <a:spcPts val="500"/>
               </a:spcAft>
-              <a:buNone/>
+              <a:buSzPct val="100000"/>
+              <a:buChar char="●"/>
             </a:pPr>
             <a:r>
               <a:rPr lang="en-US" sz="1400" dirty="0">
@@ -6489,28 +5800,15 @@
             <a:endParaRPr lang="en-US" sz="1550" dirty="0"/>
           </a:p>
           <a:p>
-            <a:pPr lvl="1" indent="0" marL="0">
-              <a:buNone/>
-            </a:pPr>
-            <a:r>
-              <a:rPr lang="en-US" sz="1150" dirty="0">
-                <a:solidFill>
-                  <a:srgbClr val="1D4ED8"/>
-                </a:solidFill>
-                <a:latin typeface="Pretendard" pitchFamily="34" charset="0"/>
-                <a:ea typeface="Pretendard" pitchFamily="34" charset="-122"/>
-                <a:cs typeface="Pretendard" pitchFamily="34" charset="-120"/>
-              </a:rPr>
-              <a:t>●   </a:t>
-            </a:r>
-            <a:pPr lvl="1" indent="0" marL="0">
-              <a:lnSpc>
-                <a:spcPct val="120000"/>
+            <a:pPr lvl="1" marL="457200" indent="-228600">
+              <a:lnSpc>
+                <a:spcPct val="125000"/>
               </a:lnSpc>
               <a:spcAft>
                 <a:spcPts val="500"/>
               </a:spcAft>
-              <a:buNone/>
+              <a:buSzPct val="100000"/>
+              <a:buChar char="●"/>
             </a:pPr>
             <a:r>
               <a:rPr lang="en-US" sz="1400" dirty="0">
@@ -6526,28 +5824,15 @@
             <a:endParaRPr lang="en-US" sz="1550" dirty="0"/>
           </a:p>
           <a:p>
-            <a:pPr lvl="1" indent="0" marL="0">
-              <a:buNone/>
-            </a:pPr>
-            <a:r>
-              <a:rPr lang="en-US" sz="1150" dirty="0">
-                <a:solidFill>
-                  <a:srgbClr val="1D4ED8"/>
-                </a:solidFill>
-                <a:latin typeface="Pretendard" pitchFamily="34" charset="0"/>
-                <a:ea typeface="Pretendard" pitchFamily="34" charset="-122"/>
-                <a:cs typeface="Pretendard" pitchFamily="34" charset="-120"/>
-              </a:rPr>
-              <a:t>●   </a:t>
-            </a:r>
-            <a:pPr lvl="1" indent="0" marL="0">
-              <a:lnSpc>
-                <a:spcPct val="120000"/>
+            <a:pPr lvl="1" marL="457200" indent="-228600">
+              <a:lnSpc>
+                <a:spcPct val="125000"/>
               </a:lnSpc>
               <a:spcAft>
                 <a:spcPts val="500"/>
               </a:spcAft>
-              <a:buNone/>
+              <a:buSzPct val="100000"/>
+              <a:buChar char="●"/>
             </a:pPr>
             <a:r>
               <a:rPr lang="en-US" sz="1400" dirty="0">
@@ -6861,45 +6146,15 @@
           <a:bodyPr wrap="square" lIns="0" tIns="0" rIns="0" bIns="0" rtlCol="0" anchor="t"/>
           <a:lstStyle/>
           <a:p>
-            <a:pPr lvl="1" indent="0" marL="0">
-              <a:buNone/>
-            </a:pPr>
-            <a:r>
-              <a:rPr lang="en-US" sz="1150" dirty="0">
-                <a:solidFill>
-                  <a:srgbClr val="1D4ED8"/>
-                </a:solidFill>
-                <a:latin typeface="Pretendard" pitchFamily="34" charset="0"/>
-                <a:ea typeface="Pretendard" pitchFamily="34" charset="-122"/>
-                <a:cs typeface="Pretendard" pitchFamily="34" charset="-120"/>
-              </a:rPr>
-              <a:t>●   </a:t>
-            </a:r>
-            <a:pPr lvl="1" indent="0" marL="0">
-              <a:lnSpc>
-                <a:spcPct val="120000"/>
-              </a:lnSpc>
-              <a:buNone/>
-            </a:pPr>
-            <a:r>
-              <a:rPr lang="en-US" sz="1400" b="1" dirty="0">
-                <a:solidFill>
-                  <a:srgbClr val="111827"/>
-                </a:solidFill>
-                <a:latin typeface="Pretendard" pitchFamily="34" charset="0"/>
-                <a:ea typeface="Pretendard" pitchFamily="34" charset="-122"/>
-                <a:cs typeface="Pretendard" pitchFamily="34" charset="-120"/>
-              </a:rPr>
-              <a:t>PE on/off   </a:t>
-            </a:r>
-            <a:pPr lvl="1" indent="0" marL="0">
-              <a:lnSpc>
-                <a:spcPct val="120000"/>
+            <a:pPr lvl="1" marL="457200" indent="-228600">
+              <a:lnSpc>
+                <a:spcPct val="125000"/>
               </a:lnSpc>
               <a:spcAft>
                 <a:spcPts val="500"/>
               </a:spcAft>
-              <a:buNone/>
+              <a:buSzPct val="100000"/>
+              <a:buChar char="●"/>
             </a:pPr>
             <a:r>
               <a:rPr lang="en-US" sz="1400" dirty="0">
@@ -6910,50 +6165,20 @@
                 <a:ea typeface="Pretendard" pitchFamily="34" charset="-122"/>
                 <a:cs typeface="Pretendard" pitchFamily="34" charset="-120"/>
               </a:rPr>
-              <a:t>with-PE 0.910 vs no-PE 0.911 (차이 -0.001) → 순서 정보가 거의 불필요</a:t>
-            </a:r>
-            <a:endParaRPr lang="en-US" sz="1150" dirty="0"/>
-          </a:p>
-          <a:p>
-            <a:pPr lvl="1" indent="0" marL="0">
-              <a:buNone/>
-            </a:pPr>
-            <a:r>
-              <a:rPr lang="en-US" sz="1150" dirty="0">
-                <a:solidFill>
-                  <a:srgbClr val="1D4ED8"/>
-                </a:solidFill>
-                <a:latin typeface="Pretendard" pitchFamily="34" charset="0"/>
-                <a:ea typeface="Pretendard" pitchFamily="34" charset="-122"/>
-                <a:cs typeface="Pretendard" pitchFamily="34" charset="-120"/>
-              </a:rPr>
-              <a:t>●   </a:t>
-            </a:r>
-            <a:pPr lvl="1" indent="0" marL="0">
-              <a:lnSpc>
-                <a:spcPct val="120000"/>
-              </a:lnSpc>
-              <a:buNone/>
-            </a:pPr>
-            <a:r>
-              <a:rPr lang="en-US" sz="1400" b="1" dirty="0">
-                <a:solidFill>
-                  <a:srgbClr val="111827"/>
-                </a:solidFill>
-                <a:latin typeface="Pretendard" pitchFamily="34" charset="0"/>
-                <a:ea typeface="Pretendard" pitchFamily="34" charset="-122"/>
-                <a:cs typeface="Pretendard" pitchFamily="34" charset="-120"/>
-              </a:rPr>
-              <a:t>robustness   </a:t>
-            </a:r>
-            <a:pPr lvl="1" indent="0" marL="0">
-              <a:lnSpc>
-                <a:spcPct val="120000"/>
+              <a:t>PE on/off : with-PE 0.910 vs no-PE 0.911 (차이 -0.001) → 순서 정보가 거의 불필요</a:t>
+            </a:r>
+            <a:endParaRPr lang="en-US" sz="1400" dirty="0"/>
+          </a:p>
+          <a:p>
+            <a:pPr lvl="1" marL="457200" indent="-228600">
+              <a:lnSpc>
+                <a:spcPct val="125000"/>
               </a:lnSpc>
               <a:spcAft>
                 <a:spcPts val="500"/>
               </a:spcAft>
-              <a:buNone/>
+              <a:buSzPct val="100000"/>
+              <a:buChar char="●"/>
             </a:pPr>
             <a:r>
               <a:rPr lang="en-US" sz="1400" dirty="0">
@@ -6964,9 +6189,9 @@
                 <a:ea typeface="Pretendard" pitchFamily="34" charset="-122"/>
                 <a:cs typeface="Pretendard" pitchFamily="34" charset="-120"/>
               </a:rPr>
-              <a:t>LSTM은 비주제어 'giddy'에 쏠려 오답, Transformer는 주제 토큰에 분산하여 정답</a:t>
-            </a:r>
-            <a:endParaRPr lang="en-US" sz="1150" dirty="0"/>
+              <a:t>robustness : LSTM은 비주제어 'giddy'에 쏠려 오답, Transformer는 주제 토큰에 분산해 정답</a:t>
+            </a:r>
+            <a:endParaRPr lang="en-US" sz="1400" dirty="0"/>
           </a:p>
         </p:txBody>
       </p:sp>

</xml_diff>